<commit_message>
Add Santa Elena (Talca) renders and update cover image
- Slide 7 (Santa Elena): entry gate render fills full 4.55"×2.45" frame,
  placeholder caption cleared
- Cover: large top-right image updated to Santa Elena strip center render
- Assets: 3 Santa Elena renders added (gate, strip center, loteo aerial)

Co-Authored-By: Claude Sonnet 4.6 <noreply@anthropic.com>
Claude-Session: https://claude.ai/code/session_0163BjnHaCEdUsmS8WNR9km7
</commit_message>
<xml_diff>
--- a/Portafolio_Inversion_Magna_2026_MAGNA.pptx
+++ b/Portafolio_Inversion_Magna_2026_MAGNA.pptx
@@ -16412,8 +16412,8 @@
         </p:blipFill>
         <p:spPr>
           <a:xfrm>
-            <a:off x="2144268" y="3034894"/>
-            <a:ext cx="1005840" cy="1005840"/>
+            <a:off x="566928" y="2542032"/>
+            <a:ext cx="4160520" cy="2240280"/>
           </a:xfrm>
           <a:prstGeom prst="rect">
             <a:avLst/>
@@ -16492,7 +16492,7 @@
                 <a:ea typeface="Calibri" pitchFamily="34" charset="-122"/>
                 <a:cs typeface="Calibri" pitchFamily="34" charset="-120"/>
               </a:rPr>
-              <a:t>Imagen referencial · render por incorporar</a:t>
+              <a:t/>
             </a:r>
             <a:endParaRPr lang="en-US" sz="850" dirty="0"/>
           </a:p>

</xml_diff>

<commit_message>
Add Alto Serena VI (La Serena) renders to presentation
- Slide 8: entry gate render fills full frame, placeholder caption cleared
- Assets: 3 renders added (entry gate, front view, aerial)

Co-Authored-By: Claude Sonnet 4.6 <noreply@anthropic.com>
Claude-Session: https://claude.ai/code/session_0163BjnHaCEdUsmS8WNR9km7
</commit_message>
<xml_diff>
--- a/Portafolio_Inversion_Magna_2026_MAGNA.pptx
+++ b/Portafolio_Inversion_Magna_2026_MAGNA.pptx
@@ -18525,8 +18525,8 @@
         </p:blipFill>
         <p:spPr>
           <a:xfrm>
-            <a:off x="2144268" y="3034894"/>
-            <a:ext cx="1005840" cy="1005840"/>
+            <a:off x="566928" y="2542032"/>
+            <a:ext cx="4160520" cy="2240280"/>
           </a:xfrm>
           <a:prstGeom prst="rect">
             <a:avLst/>
@@ -18605,7 +18605,7 @@
                 <a:ea typeface="Calibri" pitchFamily="34" charset="-122"/>
                 <a:cs typeface="Calibri" pitchFamily="34" charset="-120"/>
               </a:rPr>
-              <a:t>Imagen referencial · render por incorporar</a:t>
+              <a:t/>
             </a:r>
             <a:endParaRPr lang="en-US" sz="850" dirty="0"/>
           </a:p>

</xml_diff>

<commit_message>
Complete presentation — add Lo Curro (Vía Celeste) renders, all 5 projects done
- Slide 10 (Lo Curro): sunset access render fills full 4.10"×4.10" frame
- Cover: bottom-right updated to Lo Curro access (Las Condes / Vive Radal / Lo Curro)
- Assets: 4 Lo Curro renders added (access sunset, night, exterior, terrace)
- All 5 project slides now have real renders with Magna logo on every slide

Co-Authored-By: Claude Sonnet 4.6 <noreply@anthropic.com>
Claude-Session: https://claude.ai/code/session_0163BjnHaCEdUsmS8WNR9km7
</commit_message>
<xml_diff>
--- a/Portafolio_Inversion_Magna_2026_MAGNA.pptx
+++ b/Portafolio_Inversion_Magna_2026_MAGNA.pptx
@@ -2966,8 +2966,8 @@
         </p:blipFill>
         <p:spPr>
           <a:xfrm>
-            <a:off x="1938528" y="3202229"/>
-            <a:ext cx="1005840" cy="1005840"/>
+            <a:off x="566928" y="2377440"/>
+            <a:ext cx="3749039" cy="3749039"/>
           </a:xfrm>
           <a:prstGeom prst="rect">
             <a:avLst/>
@@ -3046,7 +3046,7 @@
                 <a:ea typeface="Calibri" pitchFamily="34" charset="-122"/>
                 <a:cs typeface="Calibri" pitchFamily="34" charset="-120"/>
               </a:rPr>
-              <a:t>Imagen referencial · render por incorporar</a:t>
+              <a:t/>
             </a:r>
             <a:endParaRPr lang="en-US" sz="850" dirty="0"/>
           </a:p>

</xml_diff>